<commit_message>
bench(netlib): the full set and its certified gaps at main 945cb4f on a GitHub-hosted runner, 94 of 94 exact and verified, 91 of 94 certified
bench.yml runs 39205763590 (netlib-full) and 39205767431 (netlib-certified), 120 s, github-actions ubuntu-latest 4 vCPU AMD EPYC 7763, 15 GiB, from the tracked data/netlib files with a clean stamp. 94 of 94 within 1e-6 of Koch's exact optimum and verified; 83 of 94 match the readme. 91 of 94 optimal answers are certified to 1e-6 by the Neumaier-Shcherbina bound of their duals (worst 5.1e-08). maros-r7 now ends ipm+crossover at a vertex with a certified relative gap of 3.25e-12 (no finite bound at 736a1106). pilot87 is finite but looser (6.26e-06), and greenbea and greenbeb have no finite bound. pilot87 solves in 47.8 s and d2q06c's exact step completes, both inside the limit. BENCHMARKS 1c and 1c.2, the README scoreboard and the jury report are regenerated by their scripts.
</commit_message>
<xml_diff>
--- a/docs/SANKHYA-deck.pptx
+++ b/docs/SANKHYA-deck.pptx
@@ -3813,7 +3813,7 @@
                   <a:srgbClr val="555555"/>
                 </a:solidFill>
               </a:rPr>
-              <a:t>Source: bench/results/head-to-head-netlib-5e490ef.csv; bench/results/head-to-head-kennington-1860864.csv; bench/results/mittelmann-72123ff.csv; bench/results/miplib-ad57c03.csv; bench/results/stress-d32b3847.csv; bench/results/certified-gap-netlib-full-736a1106.csv; docs/NEGATIVE-RESULTS.md</a:t>
+              <a:t>Source: bench/results/head-to-head-netlib-5e490ef.csv; bench/results/head-to-head-kennington-1860864.csv; bench/results/mittelmann-72123ff.csv; bench/results/miplib-ad57c03.csv; bench/results/stress-d32b3847.csv; bench/results/certified-gap-netlib-full-945cb4f.csv; docs/NEGATIVE-RESULTS.md</a:t>
             </a:r>
           </a:p>
         </p:txBody>
@@ -3896,7 +3896,7 @@
                   <a:srgbClr val="555555"/>
                 </a:solidFill>
               </a:rPr>
-              <a:t>Declined instances: stress set 15 of 126 declined (0 wrong); Maros-Meszaros 116 of 138 optimal; safe bounds, 3 of 94 optimal answers with no finite bound, and they say so.</a:t>
+              <a:t>Declined instances: stress set 15 of 126 declined (0 wrong); Maros-Meszaros 116 of 138 optimal; safe bounds, 2 of 94 optimal answers with no finite bound, and they say so.</a:t>
             </a:r>
           </a:p>
           <a:p>
@@ -6548,7 +6548,7 @@
                   <a:srgbClr val="555555"/>
                 </a:solidFill>
               </a:rPr>
-              <a:t>Source: bench/results/netlib-full-9094e1c.csv, bench/results/netlib-infeasible-5a39fb2.csv, bench/results/certified-gap-netlib-full-736a1106.csv, bench/results/exact-sensitivity-60455ce.csv, bench/results/stress-d32b3847.csv</a:t>
+              <a:t>Source: bench/results/netlib-full-945cb4f.csv, bench/results/netlib-infeasible-5a39fb2.csv, bench/results/certified-gap-netlib-full-945cb4f.csv, bench/results/exact-sensitivity-60455ce.csv, bench/results/stress-d32b3847.csv</a:t>
             </a:r>
           </a:p>
         </p:txBody>
@@ -6696,7 +6696,7 @@
                             <a:srgbClr val="555555"/>
                           </a:solidFill>
                         </a:rPr>
-                        <a:t>92 of 92</a:t>
+                        <a:t>94 of 94</a:t>
                       </a:r>
                     </a:p>
                   </a:txBody>
@@ -6717,7 +6717,7 @@
                             <a:srgbClr val="555555"/>
                           </a:solidFill>
                         </a:rPr>
-                        <a:t>bench/results/netlib-full-9094e1c.csv</a:t>
+                        <a:t>bench/results/netlib-full-945cb4f.csv</a:t>
                       </a:r>
                     </a:p>
                   </a:txBody>
@@ -6738,7 +6738,7 @@
                             <a:srgbClr val="555555"/>
                           </a:solidFill>
                         </a:rPr>
-                        <a:t>9094e1c</a:t>
+                        <a:t>945cb4f</a:t>
                       </a:r>
                     </a:p>
                   </a:txBody>
@@ -6782,7 +6782,7 @@
                             <a:srgbClr val="555555"/>
                           </a:solidFill>
                         </a:rPr>
-                        <a:t>90 of 92</a:t>
+                        <a:t>94 of 94</a:t>
                       </a:r>
                     </a:p>
                   </a:txBody>
@@ -6803,7 +6803,7 @@
                             <a:srgbClr val="555555"/>
                           </a:solidFill>
                         </a:rPr>
-                        <a:t>bench/results/netlib-full-9094e1c.csv</a:t>
+                        <a:t>bench/results/netlib-full-945cb4f.csv</a:t>
                       </a:r>
                     </a:p>
                   </a:txBody>
@@ -6824,7 +6824,7 @@
                             <a:srgbClr val="555555"/>
                           </a:solidFill>
                         </a:rPr>
-                        <a:t>9094e1c</a:t>
+                        <a:t>945cb4f</a:t>
                       </a:r>
                     </a:p>
                   </a:txBody>
@@ -6954,7 +6954,7 @@
                             <a:srgbClr val="555555"/>
                           </a:solidFill>
                         </a:rPr>
-                        <a:t>90 of 94</a:t>
+                        <a:t>91 of 94</a:t>
                       </a:r>
                     </a:p>
                   </a:txBody>
@@ -6975,7 +6975,7 @@
                             <a:srgbClr val="555555"/>
                           </a:solidFill>
                         </a:rPr>
-                        <a:t>bench/results/certified-gap-netlib-full-736a1106.csv</a:t>
+                        <a:t>bench/results/certified-gap-netlib-full-945cb4f.csv</a:t>
                       </a:r>
                     </a:p>
                   </a:txBody>
@@ -6996,7 +6996,7 @@
                             <a:srgbClr val="555555"/>
                           </a:solidFill>
                         </a:rPr>
-                        <a:t>736a1106</a:t>
+                        <a:t>945cb4f</a:t>
                       </a:r>
                     </a:p>
                   </a:txBody>

</xml_diff>

<commit_message>
bench(netlib): certified gaps at main 92ef682, 92 of 94 certified and 94 of 94 verified (#1082)
</commit_message>
<xml_diff>
--- a/docs/SANKHYA-deck.pptx
+++ b/docs/SANKHYA-deck.pptx
@@ -3813,7 +3813,7 @@
                   <a:srgbClr val="555555"/>
                 </a:solidFill>
               </a:rPr>
-              <a:t>Source: bench/results/head-to-head-netlib-5e490ef.csv; bench/results/head-to-head-kennington-1860864.csv; bench/results/mittelmann-72123ff.csv; bench/results/miplib-ad57c03.csv; bench/results/stress-d32b3847.csv; bench/results/certified-gap-netlib-full-945cb4f.csv; docs/NEGATIVE-RESULTS.md</a:t>
+              <a:t>Source: bench/results/head-to-head-netlib-5e490ef.csv; bench/results/head-to-head-kennington-1860864.csv; bench/results/mittelmann-72123ff.csv; bench/results/miplib-ad57c03.csv; bench/results/stress-d32b3847.csv; bench/results/certified-gap-netlib-full-92ef682.csv; docs/NEGATIVE-RESULTS.md</a:t>
             </a:r>
           </a:p>
         </p:txBody>
@@ -3896,7 +3896,7 @@
                   <a:srgbClr val="555555"/>
                 </a:solidFill>
               </a:rPr>
-              <a:t>Declined instances: stress set 15 of 126 declined (0 wrong); Maros-Meszaros 119 of 138 optimal; safe bounds, 2 of 94 optimal answers with no finite bound, and they say so.</a:t>
+              <a:t>Declined instances: stress set 15 of 126 declined (0 wrong); Maros-Meszaros 119 of 138 optimal; safe bounds, 0 of 94 optimal answers with no finite bound, and they say so.</a:t>
             </a:r>
           </a:p>
           <a:p>
@@ -6548,7 +6548,7 @@
                   <a:srgbClr val="555555"/>
                 </a:solidFill>
               </a:rPr>
-              <a:t>Source: bench/results/netlib-full-945cb4f.csv, bench/results/netlib-infeasible-5a39fb2.csv, bench/results/certified-gap-netlib-full-945cb4f.csv, bench/results/exact-sensitivity-60455ce.csv, bench/results/stress-d32b3847.csv</a:t>
+              <a:t>Source: bench/results/netlib-full-945cb4f.csv, bench/results/netlib-infeasible-5a39fb2.csv, bench/results/certified-gap-netlib-full-92ef682.csv, bench/results/exact-sensitivity-60455ce.csv, bench/results/stress-d32b3847.csv</a:t>
             </a:r>
           </a:p>
         </p:txBody>
@@ -6954,7 +6954,7 @@
                             <a:srgbClr val="555555"/>
                           </a:solidFill>
                         </a:rPr>
-                        <a:t>91 of 94</a:t>
+                        <a:t>92 of 94</a:t>
                       </a:r>
                     </a:p>
                   </a:txBody>
@@ -6975,7 +6975,7 @@
                             <a:srgbClr val="555555"/>
                           </a:solidFill>
                         </a:rPr>
-                        <a:t>bench/results/certified-gap-netlib-full-945cb4f.csv</a:t>
+                        <a:t>bench/results/certified-gap-netlib-full-92ef682.csv</a:t>
                       </a:r>
                     </a:p>
                   </a:txBody>
@@ -6996,7 +6996,7 @@
                             <a:srgbClr val="555555"/>
                           </a:solidFill>
                         </a:rPr>
-                        <a:t>945cb4f</a:t>
+                        <a:t>92ef682</a:t>
                       </a:r>
                     </a:p>
                   </a:txBody>

</xml_diff>

<commit_message>
bench(netlib): certified gaps at main 81b812c, 93 of 94 certified with certified_gap_seconds=120 (#1082)
</commit_message>
<xml_diff>
--- a/docs/SANKHYA-deck.pptx
+++ b/docs/SANKHYA-deck.pptx
@@ -3813,7 +3813,7 @@
                   <a:srgbClr val="555555"/>
                 </a:solidFill>
               </a:rPr>
-              <a:t>Source: bench/results/head-to-head-netlib-5e490ef.csv; bench/results/head-to-head-kennington-1860864.csv; bench/results/mittelmann-72123ff.csv; bench/results/miplib-ad57c03.csv; bench/results/stress-d32b3847.csv; bench/results/certified-gap-netlib-full-92ef682.csv; docs/NEGATIVE-RESULTS.md</a:t>
+              <a:t>Source: bench/results/head-to-head-netlib-5e490ef.csv; bench/results/head-to-head-kennington-1860864.csv; bench/results/mittelmann-72123ff.csv; bench/results/miplib-ad57c03.csv; bench/results/stress-d32b3847.csv; bench/results/certified-gap-netlib-full-81b812c.csv; docs/NEGATIVE-RESULTS.md</a:t>
             </a:r>
           </a:p>
         </p:txBody>
@@ -6548,7 +6548,7 @@
                   <a:srgbClr val="555555"/>
                 </a:solidFill>
               </a:rPr>
-              <a:t>Source: bench/results/netlib-full-945cb4f.csv, bench/results/netlib-infeasible-5a39fb2.csv, bench/results/certified-gap-netlib-full-92ef682.csv, bench/results/exact-sensitivity-60455ce.csv, bench/results/stress-d32b3847.csv</a:t>
+              <a:t>Source: bench/results/netlib-full-945cb4f.csv, bench/results/netlib-infeasible-5a39fb2.csv, bench/results/certified-gap-netlib-full-81b812c.csv, bench/results/exact-sensitivity-60455ce.csv, bench/results/stress-d32b3847.csv</a:t>
             </a:r>
           </a:p>
         </p:txBody>
@@ -6954,7 +6954,7 @@
                             <a:srgbClr val="555555"/>
                           </a:solidFill>
                         </a:rPr>
-                        <a:t>92 of 94</a:t>
+                        <a:t>93 of 94</a:t>
                       </a:r>
                     </a:p>
                   </a:txBody>
@@ -6975,7 +6975,7 @@
                             <a:srgbClr val="555555"/>
                           </a:solidFill>
                         </a:rPr>
-                        <a:t>bench/results/certified-gap-netlib-full-92ef682.csv</a:t>
+                        <a:t>bench/results/certified-gap-netlib-full-81b812c.csv</a:t>
                       </a:r>
                     </a:p>
                   </a:txBody>
@@ -6996,7 +6996,7 @@
                             <a:srgbClr val="555555"/>
                           </a:solidFill>
                         </a:rPr>
-                        <a:t>92ef682</a:t>
+                        <a:t>81b812c</a:t>
                       </a:r>
                     </a:p>
                   </a:txBody>

</xml_diff>

<commit_message>
bench(maros-meszaros): run on main at c766eaeb, 127 of 138 matched and 132 verified; README, BENCHMARKS, REPORT and deck regenerated (#981)
</commit_message>
<xml_diff>
--- a/docs/SANKHYA-deck.pptx
+++ b/docs/SANKHYA-deck.pptx
@@ -3896,7 +3896,7 @@
                   <a:srgbClr val="555555"/>
                 </a:solidFill>
               </a:rPr>
-              <a:t>Declined instances: stress set 15 of 126 declined (0 wrong); Maros-Meszaros 119 of 138 optimal; safe bounds, 0 of 94 optimal answers with no finite bound, and they say so.</a:t>
+              <a:t>Declined instances: stress set 15 of 126 declined (0 wrong); Maros-Meszaros 128 of 138 optimal; safe bounds, 0 of 94 optimal answers with no finite bound, and they say so.</a:t>
             </a:r>
           </a:p>
           <a:p>
@@ -8996,7 +8996,7 @@
                   <a:srgbClr val="555555"/>
                 </a:solidFill>
               </a:rPr>
-              <a:t>Source: bench/results/head-to-head-maros-meszaros-d0eb672.csv (d0eb672); bench/results/maros-meszaros-cad720c.csv (cad720c); bench/results/miplib-ad57c03.csv (ad57c03)</a:t>
+              <a:t>Source: bench/results/head-to-head-maros-meszaros-d0eb672.csv (d0eb672); bench/results/maros-meszaros-c766eae.csv (c766eae); bench/results/miplib-ad57c03.csv (ad57c03)</a:t>
             </a:r>
           </a:p>
         </p:txBody>
@@ -10397,7 +10397,7 @@
                   <a:srgbClr val="555555"/>
                 </a:solidFill>
               </a:rPr>
-              <a:t>Alone, on the laptop: 117 of 138 at the published objective, 0 optimal answers rejected (bench/results/maros-meszaros-cad720c.csv).</a:t>
+              <a:t>Alone, on the laptop: 127 of 138 at the published objective, 0 optimal answers rejected (bench/results/maros-meszaros-c766eae.csv).</a:t>
             </a:r>
           </a:p>
         </p:txBody>

</xml_diff>